<commit_message>
Docs/visuals for executable stego: presentation slide, Arabic guide, capture pipelines, completion report
- gui_smoke_test: extra evidence shot malware_exec_stego.png (hide+scan
  populated view) alongside the 20-view gallery.
- build_presentation: slide 10b (executable stego), updated agenda +
  honesty bullets; deck now 21 slides.
- capture_all_services: 4 new real steps (hide/scan/extract/flag) -
  33/33 screenshots.
- capture_technique_steps: steps 34b/34c/34d - numbered set now 39.
- build_user_guide_ar: section 10 renamed to Malware & Executable Stego
  with 5 real screenshots; reports/extraction shots renumbered.
- COMPLETION_REPORT: gap-closing update, 34 tests, verification status,
  remaining constraints.
- Verified: pytest 34 passed; preflight READY (21 PASS / 1 GATED / 1
  BLOCKED-by-design).
</commit_message>
<xml_diff>
--- a/StegoNexus_Presentation.pptx
+++ b/StegoNexus_Presentation.pptx
@@ -25,6 +25,7 @@
     <p:sldId id="273" r:id="rId24"/>
     <p:sldId id="274" r:id="rId25"/>
     <p:sldId id="275" r:id="rId26"/>
+    <p:sldId id="276" r:id="rId27"/>
   </p:sldIdLst>
   <p:sldSz cx="12191695" cy="6858000" type="screen4x3"/>
   <p:notesSz cx="6858000" cy="9144000"/>
@@ -3568,14 +3569,14 @@
                   <a:srgbClr val="E6F0FB"/>
                 </a:solidFill>
               </a:rPr>
-              <a:t>11. Hashing &amp; integrity: MD5..SHA-512 with MATCH / MISMATCH</a:t>
+              <a:t>10b. Executable stego: hide/extract in PE overlay &amp; slack - and its detection</a:t>
             </a:r>
           </a:p>
         </p:txBody>
       </p:sp>
       <p:pic>
         <p:nvPicPr>
-          <p:cNvPr id="3" name="Picture 2" descr="hashing.png"/>
+          <p:cNvPr id="3" name="Picture 2" descr="malware_exec_stego.png"/>
           <p:cNvPicPr>
             <a:picLocks noChangeAspect="1"/>
           </p:cNvPicPr>
@@ -3651,14 +3652,14 @@
                   <a:srgbClr val="E6F0FB"/>
                 </a:solidFill>
               </a:rPr>
-              <a:t>11. Cases: status workflow + synthetic training fixtures</a:t>
+              <a:t>11. Hashing &amp; integrity: MD5..SHA-512 with MATCH / MISMATCH</a:t>
             </a:r>
           </a:p>
         </p:txBody>
       </p:sp>
       <p:pic>
         <p:nvPicPr>
-          <p:cNvPr id="3" name="Picture 2" descr="cases.png"/>
+          <p:cNvPr id="3" name="Picture 2" descr="hashing.png"/>
           <p:cNvPicPr>
             <a:picLocks noChangeAspect="1"/>
           </p:cNvPicPr>
@@ -3734,14 +3735,14 @@
                   <a:srgbClr val="E6F0FB"/>
                 </a:solidFill>
               </a:rPr>
-              <a:t>11. Reports: branded PDF / HTML / JSON from stored records</a:t>
+              <a:t>11. Cases: status workflow + synthetic training fixtures</a:t>
             </a:r>
           </a:p>
         </p:txBody>
       </p:sp>
       <p:pic>
         <p:nvPicPr>
-          <p:cNvPr id="3" name="Picture 2" descr="reports.png"/>
+          <p:cNvPr id="3" name="Picture 2" descr="cases.png"/>
           <p:cNvPicPr>
             <a:picLocks noChangeAspect="1"/>
           </p:cNvPicPr>
@@ -3817,14 +3818,14 @@
                   <a:srgbClr val="E6F0FB"/>
                 </a:solidFill>
               </a:rPr>
-              <a:t>Tool Health - measured matrix; missing tools are UNAVAILABLE</a:t>
+              <a:t>11. Reports: branded PDF / HTML / JSON from stored records</a:t>
             </a:r>
           </a:p>
         </p:txBody>
       </p:sp>
       <p:pic>
         <p:nvPicPr>
-          <p:cNvPr id="3" name="Picture 2" descr="toolhealth.png"/>
+          <p:cNvPr id="3" name="Picture 2" descr="reports.png"/>
           <p:cNvPicPr>
             <a:picLocks noChangeAspect="1"/>
           </p:cNvPicPr>
@@ -3900,14 +3901,14 @@
                   <a:srgbClr val="E6F0FB"/>
                 </a:solidFill>
               </a:rPr>
-              <a:t>External Tools Matrix - REFERENCE / EXTERNAL, never faked</a:t>
+              <a:t>Tool Health - measured matrix; missing tools are UNAVAILABLE</a:t>
             </a:r>
           </a:p>
         </p:txBody>
       </p:sp>
       <p:pic>
         <p:nvPicPr>
-          <p:cNvPr id="3" name="Picture 2" descr="externaltools.png"/>
+          <p:cNvPr id="3" name="Picture 2" descr="toolhealth.png"/>
           <p:cNvPicPr>
             <a:picLocks noChangeAspect="1"/>
           </p:cNvPicPr>
@@ -3983,14 +3984,14 @@
                   <a:srgbClr val="E6F0FB"/>
                 </a:solidFill>
               </a:rPr>
-              <a:t>Light theme - the same UI in both themes</a:t>
+              <a:t>External Tools Matrix - REFERENCE / EXTERNAL, never faked</a:t>
             </a:r>
           </a:p>
         </p:txBody>
       </p:sp>
       <p:pic>
         <p:nvPicPr>
-          <p:cNvPr id="3" name="Picture 2" descr="dashboard-light.png"/>
+          <p:cNvPr id="3" name="Picture 2" descr="externaltools.png"/>
           <p:cNvPicPr>
             <a:picLocks noChangeAspect="1"/>
           </p:cNvPicPr>
@@ -4180,7 +4181,7 @@
                   <a:srgbClr val="E6F0FB"/>
                 </a:solidFill>
               </a:rPr>
-              <a:t>6. Defensive malware analysis</a:t>
+              <a:t>6. Defensive malware analysis + executable stego (overlay/slack)</a:t>
             </a:r>
           </a:p>
           <a:p>
@@ -4264,6 +4265,89 @@
           <a:lstStyle/>
           <a:p>
             <a:r>
+              <a:rPr sz="2200" b="1">
+                <a:solidFill>
+                  <a:srgbClr val="E6F0FB"/>
+                </a:solidFill>
+              </a:rPr>
+              <a:t>Light theme - the same UI in both themes</a:t>
+            </a:r>
+          </a:p>
+        </p:txBody>
+      </p:sp>
+      <p:pic>
+        <p:nvPicPr>
+          <p:cNvPr id="3" name="Picture 2" descr="dashboard-light.png"/>
+          <p:cNvPicPr>
+            <a:picLocks noChangeAspect="1"/>
+          </p:cNvPicPr>
+          <p:nvPr/>
+        </p:nvPicPr>
+        <p:blipFill>
+          <a:blip r:embed="rId2"/>
+          <a:stretch>
+            <a:fillRect/>
+          </a:stretch>
+        </p:blipFill>
+        <p:spPr>
+          <a:xfrm>
+            <a:off x="1005840" y="1097280"/>
+            <a:ext cx="10149840" cy="6752463"/>
+          </a:xfrm>
+          <a:prstGeom prst="rect">
+            <a:avLst/>
+          </a:prstGeom>
+        </p:spPr>
+      </p:pic>
+    </p:spTree>
+  </p:cSld>
+  <p:clrMapOvr>
+    <a:masterClrMapping/>
+  </p:clrMapOvr>
+</p:sld>
+</file>
+
+<file path=ppt/slides/slide21.xml><?xml version="1.0" encoding="utf-8"?>
+<p:sld xmlns:a="http://schemas.openxmlformats.org/drawingml/2006/main" xmlns:p="http://schemas.openxmlformats.org/presentationml/2006/main" xmlns:r="http://schemas.openxmlformats.org/officeDocument/2006/relationships">
+  <p:cSld>
+    <p:bg>
+      <p:bgPr>
+        <a:solidFill>
+          <a:srgbClr val="0B1220"/>
+        </a:solidFill>
+        <a:effectLst/>
+      </p:bgPr>
+    </p:bg>
+    <p:spTree>
+      <p:nvGrpSpPr>
+        <p:cNvPr id="1" name=""/>
+        <p:cNvGrpSpPr/>
+        <p:nvPr/>
+      </p:nvGrpSpPr>
+      <p:grpSpPr/>
+      <p:sp>
+        <p:nvSpPr>
+          <p:cNvPr id="2" name="TextBox 1"/>
+          <p:cNvSpPr txBox="1"/>
+          <p:nvPr/>
+        </p:nvSpPr>
+        <p:spPr>
+          <a:xfrm>
+            <a:off x="548640" y="320040"/>
+            <a:ext cx="11064240" cy="822960"/>
+          </a:xfrm>
+          <a:prstGeom prst="rect">
+            <a:avLst/>
+          </a:prstGeom>
+          <a:noFill/>
+        </p:spPr>
+        <p:txBody>
+          <a:bodyPr wrap="square">
+            <a:spAutoFit/>
+          </a:bodyPr>
+          <a:lstStyle/>
+          <a:p>
+            <a:r>
               <a:rPr sz="3000" b="1">
                 <a:solidFill>
                   <a:srgbClr val="E6F0FB"/>
@@ -4384,6 +4468,36 @@
                 </a:solidFill>
               </a:rPr>
               <a:t>• Malware analysis is static and defensive; specimens are never executed.</a:t>
+            </a:r>
+          </a:p>
+          <a:p>
+            <a:pPr>
+              <a:spcAft>
+                <a:spcPts val="600"/>
+              </a:spcAft>
+            </a:pPr>
+            <a:r>
+              <a:rPr sz="1600">
+                <a:solidFill>
+                  <a:srgbClr val="E6F0FB"/>
+                </a:solidFill>
+              </a:rPr>
+              <a:t>• Executable stego (overlay/slack) is demonstrated on synthetic, code-free</a:t>
+            </a:r>
+          </a:p>
+          <a:p>
+            <a:pPr>
+              <a:spcAft>
+                <a:spcPts val="600"/>
+              </a:spcAft>
+            </a:pPr>
+            <a:r>
+              <a:rPr sz="1600">
+                <a:solidFill>
+                  <a:srgbClr val="E6F0FB"/>
+                </a:solidFill>
+              </a:rPr>
+              <a:t>• training carriers - shown so the technique can be detected and reversed.</a:t>
             </a:r>
           </a:p>
           <a:p>

</xml_diff>

<commit_message>
Credit the developer on title & closing slides: Mohammed Moneer Al-absi
</commit_message>
<xml_diff>
--- a/StegoNexus_Presentation.pptx
+++ b/StegoNexus_Presentation.pptx
@@ -3835,8 +3835,8 @@
         </p:nvSpPr>
         <p:spPr>
           <a:xfrm>
-            <a:off x="1097280" y="5074920"/>
-            <a:ext cx="9994392" cy="1097280"/>
+            <a:off x="1097280" y="5047488"/>
+            <a:ext cx="9994392" cy="1143000"/>
           </a:xfrm>
           <a:prstGeom prst="rect">
             <a:avLst/>
@@ -3851,18 +3851,35 @@
           <a:p>
             <a:pPr algn="ctr" rtl="1">
               <a:spcAft>
-                <a:spcPts val="400"/>
-              </a:spcAft>
-            </a:pPr>
-            <a:r>
-              <a:rPr sz="1300" b="0">
+                <a:spcPts val="200"/>
+              </a:spcAft>
+            </a:pPr>
+            <a:r>
+              <a:rPr sz="1200" b="0">
+                <a:solidFill>
+                  <a:srgbClr val="93A7C4"/>
+                </a:solidFill>
+                <a:latin typeface="Segoe UI"/>
+                <a:cs typeface="Segoe UI"/>
+              </a:rPr>
+              <a:t>تطوير وإعداد:</a:t>
+            </a:r>
+          </a:p>
+          <a:p>
+            <a:pPr algn="ctr">
+              <a:spcAft>
+                <a:spcPts val="300"/>
+              </a:spcAft>
+            </a:pPr>
+            <a:r>
+              <a:rPr sz="2000" b="1">
                 <a:solidFill>
                   <a:srgbClr val="EAF2FC"/>
                 </a:solidFill>
                 <a:latin typeface="Segoe UI"/>
                 <a:cs typeface="Segoe UI"/>
               </a:rPr>
-              <a:t>إعداد وتنفيذ: ..............................................</a:t>
+              <a:t>Mohammed Moneer Al-absi</a:t>
             </a:r>
           </a:p>
           <a:p>
@@ -20112,7 +20129,7 @@
         </p:nvSpPr>
         <p:spPr>
           <a:xfrm>
-            <a:off x="1097280" y="5669280"/>
+            <a:off x="1097280" y="5257800"/>
             <a:ext cx="9994392" cy="365760"/>
           </a:xfrm>
           <a:prstGeom prst="rect">
@@ -20126,13 +20143,93 @@
           </a:bodyPr>
           <a:lstStyle/>
           <a:p>
+            <a:pPr algn="ctr" rtl="1">
+              <a:spcAft>
+                <a:spcPts val="400"/>
+              </a:spcAft>
+            </a:pPr>
+            <a:r>
+              <a:rPr sz="1200" b="0">
+                <a:solidFill>
+                  <a:srgbClr val="93A7C4"/>
+                </a:solidFill>
+                <a:latin typeface="Segoe UI"/>
+                <a:cs typeface="Segoe UI"/>
+              </a:rPr>
+              <a:t>تطوير وإعداد:</a:t>
+            </a:r>
+          </a:p>
+        </p:txBody>
+      </p:sp>
+      <p:sp>
+        <p:nvSpPr>
+          <p:cNvPr id="11" name="TextBox 10"/>
+          <p:cNvSpPr txBox="1"/>
+          <p:nvPr/>
+        </p:nvSpPr>
+        <p:spPr>
+          <a:xfrm>
+            <a:off x="1097280" y="5623560"/>
+            <a:ext cx="9994392" cy="411480"/>
+          </a:xfrm>
+          <a:prstGeom prst="rect">
+            <a:avLst/>
+          </a:prstGeom>
+          <a:noFill/>
+        </p:spPr>
+        <p:txBody>
+          <a:bodyPr wrap="square" anchor="t" lIns="0" rIns="0" tIns="0" bIns="0">
+            <a:spAutoFit/>
+          </a:bodyPr>
+          <a:lstStyle/>
+          <a:p>
             <a:pPr algn="ctr">
               <a:spcAft>
                 <a:spcPts val="400"/>
               </a:spcAft>
             </a:pPr>
             <a:r>
-              <a:rPr sz="1200" b="0">
+              <a:rPr sz="1500" b="1">
+                <a:solidFill>
+                  <a:srgbClr val="EAF2FC"/>
+                </a:solidFill>
+                <a:latin typeface="Segoe UI"/>
+                <a:cs typeface="Segoe UI"/>
+              </a:rPr>
+              <a:t>Mohammed Moneer Al-absi</a:t>
+            </a:r>
+          </a:p>
+        </p:txBody>
+      </p:sp>
+      <p:sp>
+        <p:nvSpPr>
+          <p:cNvPr id="12" name="TextBox 11"/>
+          <p:cNvSpPr txBox="1"/>
+          <p:nvPr/>
+        </p:nvSpPr>
+        <p:spPr>
+          <a:xfrm>
+            <a:off x="1097280" y="6144768"/>
+            <a:ext cx="9994392" cy="320040"/>
+          </a:xfrm>
+          <a:prstGeom prst="rect">
+            <a:avLst/>
+          </a:prstGeom>
+          <a:noFill/>
+        </p:spPr>
+        <p:txBody>
+          <a:bodyPr wrap="square" anchor="t" lIns="0" rIns="0" tIns="0" bIns="0">
+            <a:spAutoFit/>
+          </a:bodyPr>
+          <a:lstStyle/>
+          <a:p>
+            <a:pPr algn="ctr">
+              <a:spcAft>
+                <a:spcPts val="400"/>
+              </a:spcAft>
+            </a:pPr>
+            <a:r>
+              <a:rPr sz="1100" b="0">
                 <a:solidFill>
                   <a:srgbClr val="93A7C4"/>
                 </a:solidFill>

</xml_diff>